<commit_message>
Cambia el título para incluir la pendiente
Co-Authored-By: Claude Opus 5.5 <noreply@anthropic.com>
Claude-Session: https://claude.ai/code/session_013hGYcnMas7rqVWsurdM6tX
</commit_message>
<xml_diff>
--- a/presentacion/Precipitacion_y_Siniestralidad_Vial_en_Medellin.pptx
+++ b/presentacion/Precipitacion_y_Siniestralidad_Vial_en_Medellin.pptx
@@ -3112,14 +3112,14 @@
               </a:lnSpc>
             </a:pPr>
             <a:r>
-              <a:rPr lang="es-CO" sz="4600" b="1" i="0" dirty="0">
+              <a:rPr lang="es-CO" sz="4200" b="1" i="0" dirty="0">
                 <a:solidFill>
                   <a:srgbClr val="FFFFFF"/>
                 </a:solidFill>
                 <a:latin typeface="Georgia"/>
                 <a:cs typeface="Georgia"/>
               </a:rPr>
-              <a:t>Influencia de la precipitación en la siniestralidad vial del Distrito de Medellín (2022–2024)</a:t>
+              <a:t>Influencia de la precipitación y la pendiente en la siniestralidad vial del Distrito de Medellín (2022–2024)</a:t>
             </a:r>
           </a:p>
         </p:txBody>

</xml_diff>